<commit_message>
Update training slides v3
Co-Authored-By: Claude Opus 4.8 <noreply@anthropic.com>
</commit_message>
<xml_diff>
--- a/UChicago-PME-AI-Training_v3.pptx
+++ b/UChicago-PME-AI-Training_v3.pptx
@@ -291,8 +291,11 @@
     </a:lvl9pPr>
   </p:defaultTextStyle>
   <p:extLst>
+    <p:ext uri="{EFAFB233-063F-42B5-8137-9DF3F51BA10A}">
+      <p15:sldGuideLst xmlns:p15="http://schemas.microsoft.com/office/powerpoint/2012/main"/>
+    </p:ext>
     <p:ext uri="GoogleSlidesCustomDataVersion2">
-      <go:slidesCustomData xmlns:go="http://customooxmlschemas.google.com/" xmlns:ahyp="http://schemas.microsoft.com/office/drawing/2018/hyperlinkcolor" xmlns:p15="http://schemas.microsoft.com/office/powerpoint/2012/main" xmlns:p14="http://schemas.microsoft.com/office/powerpoint/2010/main" xmlns:com="http://schemas.openxmlformats.org/drawingml/2006/compatibility" xmlns:pvml="urn:schemas-microsoft-com:office:powerpoint" xmlns:v="urn:schemas-microsoft-com:vml" xmlns:o="urn:schemas-microsoft-com:office:office" xmlns:dgm="http://schemas.openxmlformats.org/drawingml/2006/diagram" xmlns:c="http://schemas.openxmlformats.org/drawingml/2006/chart" xmlns:mv="urn:schemas-microsoft-com:mac:vml" xmlns:mc="http://schemas.openxmlformats.org/markup-compatibility/2006" xmlns="" r:id="rId48" roundtripDataSignature="AMtx7mjlSHcwHVGMIm9R1lwFlkVRcDsy8Q=="/>
+      <go:slidesCustomData xmlns="" xmlns:mc="http://schemas.openxmlformats.org/markup-compatibility/2006" xmlns:mv="urn:schemas-microsoft-com:mac:vml" xmlns:c="http://schemas.openxmlformats.org/drawingml/2006/chart" xmlns:dgm="http://schemas.openxmlformats.org/drawingml/2006/diagram" xmlns:o="urn:schemas-microsoft-com:office:office" xmlns:v="urn:schemas-microsoft-com:vml" xmlns:pvml="urn:schemas-microsoft-com:office:powerpoint" xmlns:com="http://schemas.openxmlformats.org/drawingml/2006/compatibility" xmlns:p14="http://schemas.microsoft.com/office/powerpoint/2010/main" xmlns:p15="http://schemas.microsoft.com/office/powerpoint/2012/main" xmlns:ahyp="http://schemas.microsoft.com/office/drawing/2018/hyperlinkcolor" xmlns:go="http://customooxmlschemas.google.com/" r:id="rId48" roundtripDataSignature="AMtx7mjlSHcwHVGMIm9R1lwFlkVRcDsy8Q=="/>
     </p:ext>
   </p:extLst>
 </p:presentation>
@@ -18231,6 +18234,36 @@
           </a:p>
         </p:txBody>
       </p:sp>
+      <p:pic>
+        <p:nvPicPr>
+          <p:cNvPr id="2" name="Picture 1" descr="Rui (Ray) Ding">
+            <a:extLst>
+              <a:ext uri="{FF2B5EF4-FFF2-40B4-BE49-F238E27FC236}">
+                <a16:creationId xmlns:a16="http://schemas.microsoft.com/office/drawing/2014/main" id="{EE1C3151-0C7D-11D5-EC5E-FA7A054EDE5C}"/>
+              </a:ext>
+            </a:extLst>
+          </p:cNvPr>
+          <p:cNvPicPr>
+            <a:picLocks noChangeAspect="1"/>
+          </p:cNvPicPr>
+          <p:nvPr/>
+        </p:nvPicPr>
+        <p:blipFill>
+          <a:blip r:embed="rId4"/>
+          <a:stretch>
+            <a:fillRect/>
+          </a:stretch>
+        </p:blipFill>
+        <p:spPr>
+          <a:xfrm>
+            <a:off x="2279881" y="5056741"/>
+            <a:ext cx="1686192" cy="1686192"/>
+          </a:xfrm>
+          <a:prstGeom prst="rect">
+            <a:avLst/>
+          </a:prstGeom>
+        </p:spPr>
+      </p:pic>
     </p:spTree>
     <p:extLst>
       <p:ext uri="{BB962C8B-B14F-4D97-AF65-F5344CB8AC3E}">
@@ -20105,6 +20138,87 @@
           </a:prstGeom>
         </p:spPr>
       </p:pic>
+      <p:pic>
+        <p:nvPicPr>
+          <p:cNvPr id="10" name="Picture 9">
+            <a:extLst>
+              <a:ext uri="{FF2B5EF4-FFF2-40B4-BE49-F238E27FC236}">
+                <a16:creationId xmlns:a16="http://schemas.microsoft.com/office/drawing/2014/main" id="{BBDB914F-2AF5-303E-DBB2-564C24CC3843}"/>
+              </a:ext>
+            </a:extLst>
+          </p:cNvPr>
+          <p:cNvPicPr>
+            <a:picLocks noChangeAspect="1"/>
+          </p:cNvPicPr>
+          <p:nvPr/>
+        </p:nvPicPr>
+        <p:blipFill>
+          <a:blip r:embed="rId4"/>
+          <a:stretch>
+            <a:fillRect/>
+          </a:stretch>
+        </p:blipFill>
+        <p:spPr>
+          <a:xfrm>
+            <a:off x="8808591" y="0"/>
+            <a:ext cx="3383409" cy="1409415"/>
+          </a:xfrm>
+          <a:prstGeom prst="rect">
+            <a:avLst/>
+          </a:prstGeom>
+        </p:spPr>
+      </p:pic>
+      <p:sp>
+        <p:nvSpPr>
+          <p:cNvPr id="12" name="TextBox 11">
+            <a:extLst>
+              <a:ext uri="{FF2B5EF4-FFF2-40B4-BE49-F238E27FC236}">
+                <a16:creationId xmlns:a16="http://schemas.microsoft.com/office/drawing/2014/main" id="{369936E5-CADA-203E-ABB7-995683FA64A2}"/>
+              </a:ext>
+            </a:extLst>
+          </p:cNvPr>
+          <p:cNvSpPr txBox="1"/>
+          <p:nvPr/>
+        </p:nvSpPr>
+        <p:spPr>
+          <a:xfrm>
+            <a:off x="4740129" y="43160"/>
+            <a:ext cx="4068462" cy="307777"/>
+          </a:xfrm>
+          <a:prstGeom prst="rect">
+            <a:avLst/>
+          </a:prstGeom>
+          <a:noFill/>
+        </p:spPr>
+        <p:txBody>
+          <a:bodyPr wrap="square">
+            <a:spAutoFit/>
+          </a:bodyPr>
+          <a:lstStyle/>
+          <a:p>
+            <a:r>
+              <a:rPr lang="en-US" dirty="0"/>
+              <a:t>https://</a:t>
+            </a:r>
+            <a:r>
+              <a:rPr lang="en-US" dirty="0" err="1"/>
+              <a:t>dl.acm.org</a:t>
+            </a:r>
+            <a:r>
+              <a:rPr lang="en-US" dirty="0"/>
+              <a:t>/</a:t>
+            </a:r>
+            <a:r>
+              <a:rPr lang="en-US" dirty="0" err="1"/>
+              <a:t>doi</a:t>
+            </a:r>
+            <a:r>
+              <a:rPr lang="en-US" dirty="0"/>
+              <a:t>/10.1145/3770855.3819013</a:t>
+            </a:r>
+          </a:p>
+        </p:txBody>
+      </p:sp>
     </p:spTree>
     <p:extLst>
       <p:ext uri="{BB962C8B-B14F-4D97-AF65-F5344CB8AC3E}">

</xml_diff>